<commit_message>
update README.md, benchmark comparison, and PPT slides with actual model comparison results
</commit_message>
<xml_diff>
--- a/presentation.pptx
+++ b/presentation.pptx
@@ -5583,7 +5583,7 @@
               </a:defRPr>
             </a:pPr>
             <a:r>
-              <a:t>• Standard Validation Results (Full-Frame Evaluation):</a:t>
+              <a:t>• Model Comparison Benchmark Results (RTX 4050 GPU):</a:t>
             </a:r>
           </a:p>
           <a:p>
@@ -5599,103 +5599,119 @@
               </a:defRPr>
             </a:pPr>
             <a:r>
+              <a:t>  • YOLO11s (Parameters: 9.46M | Latency: 147.65 ms | Detections: 0)</a:t>
+            </a:r>
+          </a:p>
+          <a:p>
+            <a:pPr lvl="1">
+              <a:spcAft>
+                <a:spcPts val="1400"/>
+              </a:spcAft>
+              <a:defRPr sz="2000">
+                <a:solidFill>
+                  <a:srgbClr val="757575"/>
+                </a:solidFill>
+                <a:latin typeface="Arial"/>
+              </a:defRPr>
+            </a:pPr>
+            <a:r>
+              <a:t>  • YOLO26s (Parameters: 9.96M | Latency: 170.79 ms | Detections: 2)</a:t>
+            </a:r>
+          </a:p>
+          <a:p>
+            <a:pPr>
+              <a:spcAft>
+                <a:spcPts val="1400"/>
+              </a:spcAft>
+              <a:defRPr sz="2400" b="1">
+                <a:solidFill>
+                  <a:srgbClr val="212121"/>
+                </a:solidFill>
+                <a:latin typeface="Arial"/>
+              </a:defRPr>
+            </a:pPr>
+            <a:r>
+              <a:t>• Tiled Validation Results (YOLO26s):</a:t>
+            </a:r>
+          </a:p>
+          <a:p>
+            <a:pPr lvl="1">
+              <a:spcAft>
+                <a:spcPts val="1400"/>
+              </a:spcAft>
+              <a:defRPr sz="2000">
+                <a:solidFill>
+                  <a:srgbClr val="757575"/>
+                </a:solidFill>
+                <a:latin typeface="Arial"/>
+              </a:defRPr>
+            </a:pPr>
+            <a:r>
+              <a:t>  • Setting validation confidence threshold to 0.001 enabled proper PR curve logic.</a:t>
+            </a:r>
+          </a:p>
+          <a:p>
+            <a:pPr lvl="1">
+              <a:spcAft>
+                <a:spcPts val="1400"/>
+              </a:spcAft>
+              <a:defRPr sz="2000">
+                <a:solidFill>
+                  <a:srgbClr val="757575"/>
+                </a:solidFill>
+                <a:latin typeface="Arial"/>
+              </a:defRPr>
+            </a:pPr>
+            <a:r>
+              <a:t>  • Overall Tiled Recall achieved 24.00% (localizing correct leaf regions).</a:t>
+            </a:r>
+          </a:p>
+          <a:p>
+            <a:pPr lvl="1">
+              <a:spcAft>
+                <a:spcPts val="1400"/>
+              </a:spcAft>
+              <a:defRPr sz="2000">
+                <a:solidFill>
+                  <a:srgbClr val="757575"/>
+                </a:solidFill>
+                <a:latin typeface="Arial"/>
+              </a:defRPr>
+            </a:pPr>
+            <a:r>
+              <a:t>  • Class 'rice_disease_leaf_sheath_blight' achieved 6.31% mAP and 80.00% Recall.</a:t>
+            </a:r>
+          </a:p>
+          <a:p>
+            <a:pPr>
+              <a:spcAft>
+                <a:spcPts val="1400"/>
+              </a:spcAft>
+              <a:defRPr sz="2400" b="1">
+                <a:solidFill>
+                  <a:srgbClr val="212121"/>
+                </a:solidFill>
+                <a:latin typeface="Arial"/>
+              </a:defRPr>
+            </a:pPr>
+            <a:r>
+              <a:t>• Standard Validation Results (Full-Frame Baseline):</a:t>
+            </a:r>
+          </a:p>
+          <a:p>
+            <a:pPr lvl="1">
+              <a:spcAft>
+                <a:spcPts val="1400"/>
+              </a:spcAft>
+              <a:defRPr sz="2000">
+                <a:solidFill>
+                  <a:srgbClr val="757575"/>
+                </a:solidFill>
+                <a:latin typeface="Arial"/>
+              </a:defRPr>
+            </a:pPr>
+            <a:r>
               <a:t>  • YOLO26s Model achieved 56.84% mAP@50, 34.43% Precision, and 68.21% Recall.</a:t>
-            </a:r>
-          </a:p>
-          <a:p>
-            <a:pPr>
-              <a:spcAft>
-                <a:spcPts val="1400"/>
-              </a:spcAft>
-              <a:defRPr sz="2400" b="1">
-                <a:solidFill>
-                  <a:srgbClr val="212121"/>
-                </a:solidFill>
-                <a:latin typeface="Arial"/>
-              </a:defRPr>
-            </a:pPr>
-            <a:r>
-              <a:t>• Tiled Validation Results (Localized Evaluation for Small Pests):</a:t>
-            </a:r>
-          </a:p>
-          <a:p>
-            <a:pPr lvl="1">
-              <a:spcAft>
-                <a:spcPts val="1400"/>
-              </a:spcAft>
-              <a:defRPr sz="2000">
-                <a:solidFill>
-                  <a:srgbClr val="757575"/>
-                </a:solidFill>
-                <a:latin typeface="Arial"/>
-              </a:defRPr>
-            </a:pPr>
-            <a:r>
-              <a:t>  • Setting validation confidence threshold to 0.001 generated the full PR curves.</a:t>
-            </a:r>
-          </a:p>
-          <a:p>
-            <a:pPr lvl="1">
-              <a:spcAft>
-                <a:spcPts val="1400"/>
-              </a:spcAft>
-              <a:defRPr sz="2000">
-                <a:solidFill>
-                  <a:srgbClr val="757575"/>
-                </a:solidFill>
-                <a:latin typeface="Arial"/>
-              </a:defRPr>
-            </a:pPr>
-            <a:r>
-              <a:t>  • Tiled Validation successfully evaluated localized crop regions.</a:t>
-            </a:r>
-          </a:p>
-          <a:p>
-            <a:pPr lvl="1">
-              <a:spcAft>
-                <a:spcPts val="1400"/>
-              </a:spcAft>
-              <a:defRPr sz="2000">
-                <a:solidFill>
-                  <a:srgbClr val="757575"/>
-                </a:solidFill>
-                <a:latin typeface="Arial"/>
-              </a:defRPr>
-            </a:pPr>
-            <a:r>
-              <a:t>  • Class 'rice_disease_leaf_sheath_blight' achieved 6.31% mAP and 80.00% Recall.</a:t>
-            </a:r>
-          </a:p>
-          <a:p>
-            <a:pPr>
-              <a:spcAft>
-                <a:spcPts val="1400"/>
-              </a:spcAft>
-              <a:defRPr sz="2400" b="1">
-                <a:solidFill>
-                  <a:srgbClr val="212121"/>
-                </a:solidFill>
-                <a:latin typeface="Arial"/>
-              </a:defRPr>
-            </a:pPr>
-            <a:r>
-              <a:t>• Key Finding:</a:t>
-            </a:r>
-          </a:p>
-          <a:p>
-            <a:pPr lvl="1">
-              <a:spcAft>
-                <a:spcPts val="1400"/>
-              </a:spcAft>
-              <a:defRPr sz="2000">
-                <a:solidFill>
-                  <a:srgbClr val="757575"/>
-                </a:solidFill>
-                <a:latin typeface="Arial"/>
-              </a:defRPr>
-            </a:pPr>
-            <a:r>
-              <a:t>  • Scale-adaptation (Tiling) is mandatory. Standard YOLO drops tiny object IoUs below evaluation limits.</a:t>
             </a:r>
           </a:p>
         </p:txBody>

</xml_diff>